<commit_message>
Gezonde voeding: groen thema en derde punt
Co-Authored-By: Claude Sonnet 5.5 <noreply@anthropic.com>
Claude-Session: https://claude.ai/code/session_019dbnBAUwivFaFQixHaQrHe
</commit_message>
<xml_diff>
--- a/welzijn-presentatie.pptx
+++ b/welzijn-presentatie.pptx
@@ -912,9 +912,9 @@
             <a:avLst/>
           </a:prstGeom>
           <a:solidFill>
-            <a:schemeClr val="accent2">
+            <a:srgbClr val="4ADE80">
               <a:alpha val="15000"/>
-            </a:schemeClr>
+            </a:srgbClr>
           </a:solidFill>
           <a:ln/>
         </p:spPr>
@@ -1011,7 +1011,7 @@
             </a:avLst>
           </a:prstGeom>
           <a:solidFill>
-            <a:schemeClr val="tx2"/>
+            <a:srgbClr val="2A2866"/>
           </a:solidFill>
           <a:ln/>
         </p:spPr>
@@ -1114,9 +1114,9 @@
             <a:avLst/>
           </a:prstGeom>
           <a:solidFill>
-            <a:schemeClr val="accent1">
-              <a:alpha val="30000"/>
-            </a:schemeClr>
+            <a:srgbClr val="8B7CF6">
+              <a:alpha val="35000"/>
+            </a:srgbClr>
           </a:solidFill>
           <a:ln/>
         </p:spPr>
@@ -1196,9 +1196,9 @@
             <a:avLst/>
           </a:prstGeom>
           <a:solidFill>
-            <a:schemeClr val="accent1">
-              <a:alpha val="30000"/>
-            </a:schemeClr>
+            <a:srgbClr val="8B7CF6">
+              <a:alpha val="35000"/>
+            </a:srgbClr>
           </a:solidFill>
           <a:ln/>
         </p:spPr>
@@ -1278,9 +1278,9 @@
             <a:avLst/>
           </a:prstGeom>
           <a:solidFill>
-            <a:schemeClr val="accent1">
-              <a:alpha val="30000"/>
-            </a:schemeClr>
+            <a:srgbClr val="8B7CF6">
+              <a:alpha val="35000"/>
+            </a:srgbClr>
           </a:solidFill>
           <a:ln/>
         </p:spPr>
@@ -1362,7 +1362,7 @@
             </a:avLst>
           </a:prstGeom>
           <a:solidFill>
-            <a:schemeClr val="tx2"/>
+            <a:srgbClr val="14532D"/>
           </a:solidFill>
           <a:ln/>
         </p:spPr>
@@ -1382,7 +1382,7 @@
             <a:avLst/>
           </a:prstGeom>
           <a:solidFill>
-            <a:srgbClr val="FF8A5B"/>
+            <a:srgbClr val="4ADE80"/>
           </a:solidFill>
           <a:ln/>
         </p:spPr>
@@ -1465,9 +1465,9 @@
             <a:avLst/>
           </a:prstGeom>
           <a:solidFill>
-            <a:schemeClr val="accent1">
-              <a:alpha val="30000"/>
-            </a:schemeClr>
+            <a:srgbClr val="4ADE80">
+              <a:alpha val="35000"/>
+            </a:srgbClr>
           </a:solidFill>
           <a:ln/>
         </p:spPr>
@@ -1523,7 +1523,7 @@
             <a:r>
               <a:rPr lang="en-US" sz="1800" dirty="0">
                 <a:solidFill>
-                  <a:schemeClr val="bg2"/>
+                  <a:srgbClr val="E8FFF0"/>
                 </a:solidFill>
               </a:rPr>
               <a:t>Energie</a:t>
@@ -1547,9 +1547,9 @@
             <a:avLst/>
           </a:prstGeom>
           <a:solidFill>
-            <a:schemeClr val="accent1">
-              <a:alpha val="30000"/>
-            </a:schemeClr>
+            <a:srgbClr val="4ADE80">
+              <a:alpha val="35000"/>
+            </a:srgbClr>
           </a:solidFill>
           <a:ln/>
         </p:spPr>
@@ -1605,7 +1605,7 @@
             <a:r>
               <a:rPr lang="en-US" sz="1800" dirty="0">
                 <a:solidFill>
-                  <a:schemeClr val="bg2"/>
+                  <a:srgbClr val="E8FFF0"/>
                 </a:solidFill>
               </a:rPr>
               <a:t>Lichaam &amp; concentratie</a:t>
@@ -1616,27 +1616,29 @@
       </p:sp>
       <p:sp>
         <p:nvSpPr>
-          <p:cNvPr id="29" name="Link circle"/>
+          <p:cNvPr id="29" name="Vitaminen dot"/>
           <p:cNvSpPr/>
           <p:nvPr/>
         </p:nvSpPr>
         <p:spPr>
           <a:xfrm>
-            <a:off x="4297680" y="2720340"/>
-            <a:ext cx="365760" cy="365760"/>
+            <a:off x="4983480" y="3694176"/>
+            <a:ext cx="384048" cy="384048"/>
           </a:xfrm>
           <a:prstGeom prst="ellipse">
             <a:avLst/>
           </a:prstGeom>
           <a:solidFill>
-            <a:schemeClr val="accent4"/>
+            <a:srgbClr val="4ADE80">
+              <a:alpha val="35000"/>
+            </a:srgbClr>
           </a:solidFill>
           <a:ln/>
         </p:spPr>
       </p:sp>
       <p:pic>
         <p:nvPicPr>
-          <p:cNvPr id="30" name="Link icon" descr="Welzijn">    </p:cNvPr>
+          <p:cNvPr id="30" name="Vitaminen icon" descr="Vitaminen">    </p:cNvPr>
           <p:cNvPicPr>
             <a:picLocks noChangeAspect="1"/>
           </p:cNvPicPr>
@@ -1650,6 +1652,86 @@
         </p:blipFill>
         <p:spPr>
           <a:xfrm>
+            <a:off x="5084064" y="3794760"/>
+            <a:ext cx="182880" cy="182880"/>
+          </a:xfrm>
+          <a:prstGeom prst="rect">
+            <a:avLst/>
+          </a:prstGeom>
+        </p:spPr>
+      </p:pic>
+      <p:sp>
+        <p:nvSpPr>
+          <p:cNvPr id="31" name="Vitaminen"/>
+          <p:cNvSpPr txBox="1"/>
+          <p:nvPr/>
+        </p:nvSpPr>
+        <p:spPr>
+          <a:xfrm>
+            <a:off x="5577840" y="3694176"/>
+            <a:ext cx="2743200" cy="384048"/>
+          </a:xfrm>
+          <a:prstGeom prst="rect">
+            <a:avLst/>
+          </a:prstGeom>
+          <a:noFill/>
+          <a:ln/>
+        </p:spPr>
+        <p:txBody>
+          <a:bodyPr wrap="square" lIns="0" tIns="0" rIns="0" bIns="0" rtlCol="0" anchor="ctr"/>
+          <a:lstStyle/>
+          <a:p>
+            <a:pPr indent="0" marL="0">
+              <a:buNone/>
+            </a:pPr>
+            <a:r>
+              <a:rPr lang="en-US" sz="1800" dirty="0">
+                <a:solidFill>
+                  <a:srgbClr val="E8FFF0"/>
+                </a:solidFill>
+              </a:rPr>
+              <a:t>Vitaminen</a:t>
+            </a:r>
+            <a:endParaRPr lang="en-US" sz="1800" dirty="0"/>
+          </a:p>
+        </p:txBody>
+      </p:sp>
+      <p:sp>
+        <p:nvSpPr>
+          <p:cNvPr id="32" name="Link circle"/>
+          <p:cNvSpPr/>
+          <p:nvPr/>
+        </p:nvSpPr>
+        <p:spPr>
+          <a:xfrm>
+            <a:off x="4297680" y="2720340"/>
+            <a:ext cx="365760" cy="365760"/>
+          </a:xfrm>
+          <a:prstGeom prst="ellipse">
+            <a:avLst/>
+          </a:prstGeom>
+          <a:solidFill>
+            <a:schemeClr val="accent4"/>
+          </a:solidFill>
+          <a:ln/>
+        </p:spPr>
+      </p:sp>
+      <p:pic>
+        <p:nvPicPr>
+          <p:cNvPr id="33" name="Link icon" descr="Welzijn">    </p:cNvPr>
+          <p:cNvPicPr>
+            <a:picLocks noChangeAspect="1"/>
+          </p:cNvPicPr>
+          <p:nvPr/>
+        </p:nvPicPr>
+        <p:blipFill>
+          <a:blip r:embed="rId9"/>
+          <a:stretch>
+            <a:fillRect/>
+          </a:stretch>
+        </p:blipFill>
+        <p:spPr>
+          <a:xfrm>
             <a:off x="4389120" y="2811780"/>
             <a:ext cx="182880" cy="182880"/>
           </a:xfrm>
@@ -1660,7 +1742,7 @@
       </p:pic>
       <p:sp>
         <p:nvSpPr>
-          <p:cNvPr id="31" name="Names"/>
+          <p:cNvPr id="34" name="Names"/>
           <p:cNvSpPr txBox="1"/>
           <p:nvPr/>
         </p:nvSpPr>

</xml_diff>

<commit_message>
Voeg conclusie toe: voeding en beweging beinvloeden mentaal welzijn
Co-Authored-By: Claude Sonnet 5.5 <noreply@anthropic.com>
Claude-Session: https://claude.ai/code/session_019dbnBAUwivFaFQixHaQrHe
</commit_message>
<xml_diff>
--- a/welzijn-presentatie.pptx
+++ b/welzijn-presentatie.pptx
@@ -502,7 +502,7 @@
           <a:p>
             <a:r>
               <a:rPr lang="en-US" dirty="0"/>
-              <a:t>Presentatie van Mo B, Mo ek en Amir. Mentaal welzijn: stress, humeur, nachtrust. Gezonde voeding: energie, lichaam en concentratie.</a:t>
+              <a:t>Presentatie van Mo B, Mo ek en Amir. Mentaal welzijn: stress, humeur, nachtrust. Gezonde voeding: energie, lichaam en concentratie, vitaminen. Conclusie: gezonde voeding en beweging beinvloeden je mentaal welzijn positief.</a:t>
             </a:r>
             <a:endParaRPr lang="en-US" dirty="0"/>
           </a:p>
@@ -927,8 +927,8 @@
         </p:nvSpPr>
         <p:spPr>
           <a:xfrm>
-            <a:off x="548640" y="365760"/>
-            <a:ext cx="4572000" cy="274320"/>
+            <a:off x="548640" y="320040"/>
+            <a:ext cx="2743200" cy="274320"/>
           </a:xfrm>
           <a:prstGeom prst="rect">
             <a:avLst/>
@@ -963,8 +963,8 @@
         </p:nvSpPr>
         <p:spPr>
           <a:xfrm>
-            <a:off x="548640" y="640080"/>
-            <a:ext cx="8046720" cy="731520"/>
+            <a:off x="548640" y="594360"/>
+            <a:ext cx="8046720" cy="685800"/>
           </a:xfrm>
           <a:prstGeom prst="rect">
             <a:avLst/>
@@ -1002,7 +1002,7 @@
         </p:nvSpPr>
         <p:spPr>
           <a:xfrm>
-            <a:off x="548640" y="1645920"/>
+            <a:off x="548640" y="1463040"/>
             <a:ext cx="3931920" cy="2514600"/>
           </a:xfrm>
           <a:prstGeom prst="roundRect">
@@ -1024,7 +1024,7 @@
         </p:nvSpPr>
         <p:spPr>
           <a:xfrm>
-            <a:off x="822960" y="1901952"/>
+            <a:off x="822960" y="1719072"/>
             <a:ext cx="640080" cy="640080"/>
           </a:xfrm>
           <a:prstGeom prst="ellipse">
@@ -1052,7 +1052,7 @@
         </p:blipFill>
         <p:spPr>
           <a:xfrm>
-            <a:off x="960120" y="2039112"/>
+            <a:off x="960120" y="1856232"/>
             <a:ext cx="365760" cy="365760"/>
           </a:xfrm>
           <a:prstGeom prst="rect">
@@ -1068,7 +1068,7 @@
         </p:nvSpPr>
         <p:spPr>
           <a:xfrm>
-            <a:off x="1645920" y="1901952"/>
+            <a:off x="1645920" y="1719072"/>
             <a:ext cx="2651760" cy="640080"/>
           </a:xfrm>
           <a:prstGeom prst="rect">
@@ -1107,7 +1107,7 @@
         </p:nvSpPr>
         <p:spPr>
           <a:xfrm>
-            <a:off x="868680" y="2743200"/>
+            <a:off x="868680" y="2560320"/>
             <a:ext cx="384048" cy="384048"/>
           </a:xfrm>
           <a:prstGeom prst="ellipse">
@@ -1137,7 +1137,7 @@
         </p:blipFill>
         <p:spPr>
           <a:xfrm>
-            <a:off x="969264" y="2843784"/>
+            <a:off x="969264" y="2660904"/>
             <a:ext cx="182880" cy="182880"/>
           </a:xfrm>
           <a:prstGeom prst="rect">
@@ -1153,7 +1153,7 @@
         </p:nvSpPr>
         <p:spPr>
           <a:xfrm>
-            <a:off x="1463040" y="2743200"/>
+            <a:off x="1463040" y="2560320"/>
             <a:ext cx="2743200" cy="384048"/>
           </a:xfrm>
           <a:prstGeom prst="rect">
@@ -1189,7 +1189,7 @@
         </p:nvSpPr>
         <p:spPr>
           <a:xfrm>
-            <a:off x="868680" y="3218688"/>
+            <a:off x="868680" y="3035808"/>
             <a:ext cx="384048" cy="384048"/>
           </a:xfrm>
           <a:prstGeom prst="ellipse">
@@ -1219,7 +1219,7 @@
         </p:blipFill>
         <p:spPr>
           <a:xfrm>
-            <a:off x="969264" y="3319272"/>
+            <a:off x="969264" y="3136392"/>
             <a:ext cx="182880" cy="182880"/>
           </a:xfrm>
           <a:prstGeom prst="rect">
@@ -1235,7 +1235,7 @@
         </p:nvSpPr>
         <p:spPr>
           <a:xfrm>
-            <a:off x="1463040" y="3218688"/>
+            <a:off x="1463040" y="3035808"/>
             <a:ext cx="2743200" cy="384048"/>
           </a:xfrm>
           <a:prstGeom prst="rect">
@@ -1271,7 +1271,7 @@
         </p:nvSpPr>
         <p:spPr>
           <a:xfrm>
-            <a:off x="868680" y="3694176"/>
+            <a:off x="868680" y="3511296"/>
             <a:ext cx="384048" cy="384048"/>
           </a:xfrm>
           <a:prstGeom prst="ellipse">
@@ -1301,7 +1301,7 @@
         </p:blipFill>
         <p:spPr>
           <a:xfrm>
-            <a:off x="969264" y="3794760"/>
+            <a:off x="969264" y="3611880"/>
             <a:ext cx="182880" cy="182880"/>
           </a:xfrm>
           <a:prstGeom prst="rect">
@@ -1317,7 +1317,7 @@
         </p:nvSpPr>
         <p:spPr>
           <a:xfrm>
-            <a:off x="1463040" y="3694176"/>
+            <a:off x="1463040" y="3511296"/>
             <a:ext cx="2743200" cy="384048"/>
           </a:xfrm>
           <a:prstGeom prst="rect">
@@ -1353,7 +1353,7 @@
         </p:nvSpPr>
         <p:spPr>
           <a:xfrm>
-            <a:off x="4663440" y="1645920"/>
+            <a:off x="4663440" y="1463040"/>
             <a:ext cx="3931920" cy="2514600"/>
           </a:xfrm>
           <a:prstGeom prst="roundRect">
@@ -1375,7 +1375,7 @@
         </p:nvSpPr>
         <p:spPr>
           <a:xfrm>
-            <a:off x="4937760" y="1901952"/>
+            <a:off x="4937760" y="1719072"/>
             <a:ext cx="640080" cy="640080"/>
           </a:xfrm>
           <a:prstGeom prst="ellipse">
@@ -1403,7 +1403,7 @@
         </p:blipFill>
         <p:spPr>
           <a:xfrm>
-            <a:off x="5074920" y="2039112"/>
+            <a:off x="5074920" y="1856232"/>
             <a:ext cx="365760" cy="365760"/>
           </a:xfrm>
           <a:prstGeom prst="rect">
@@ -1419,7 +1419,7 @@
         </p:nvSpPr>
         <p:spPr>
           <a:xfrm>
-            <a:off x="5760720" y="1901952"/>
+            <a:off x="5760720" y="1719072"/>
             <a:ext cx="2651760" cy="640080"/>
           </a:xfrm>
           <a:prstGeom prst="rect">
@@ -1458,7 +1458,7 @@
         </p:nvSpPr>
         <p:spPr>
           <a:xfrm>
-            <a:off x="4983480" y="2743200"/>
+            <a:off x="4983480" y="2560320"/>
             <a:ext cx="384048" cy="384048"/>
           </a:xfrm>
           <a:prstGeom prst="ellipse">
@@ -1488,7 +1488,7 @@
         </p:blipFill>
         <p:spPr>
           <a:xfrm>
-            <a:off x="5084064" y="2843784"/>
+            <a:off x="5084064" y="2660904"/>
             <a:ext cx="182880" cy="182880"/>
           </a:xfrm>
           <a:prstGeom prst="rect">
@@ -1504,7 +1504,7 @@
         </p:nvSpPr>
         <p:spPr>
           <a:xfrm>
-            <a:off x="5577840" y="2743200"/>
+            <a:off x="5577840" y="2560320"/>
             <a:ext cx="2743200" cy="384048"/>
           </a:xfrm>
           <a:prstGeom prst="rect">
@@ -1540,7 +1540,7 @@
         </p:nvSpPr>
         <p:spPr>
           <a:xfrm>
-            <a:off x="4983480" y="3218688"/>
+            <a:off x="4983480" y="3035808"/>
             <a:ext cx="384048" cy="384048"/>
           </a:xfrm>
           <a:prstGeom prst="ellipse">
@@ -1570,7 +1570,7 @@
         </p:blipFill>
         <p:spPr>
           <a:xfrm>
-            <a:off x="5084064" y="3319272"/>
+            <a:off x="5084064" y="3136392"/>
             <a:ext cx="182880" cy="182880"/>
           </a:xfrm>
           <a:prstGeom prst="rect">
@@ -1586,7 +1586,7 @@
         </p:nvSpPr>
         <p:spPr>
           <a:xfrm>
-            <a:off x="5577840" y="3218688"/>
+            <a:off x="5577840" y="3035808"/>
             <a:ext cx="2743200" cy="384048"/>
           </a:xfrm>
           <a:prstGeom prst="rect">
@@ -1622,7 +1622,7 @@
         </p:nvSpPr>
         <p:spPr>
           <a:xfrm>
-            <a:off x="4983480" y="3694176"/>
+            <a:off x="4983480" y="3511296"/>
             <a:ext cx="384048" cy="384048"/>
           </a:xfrm>
           <a:prstGeom prst="ellipse">
@@ -1652,7 +1652,7 @@
         </p:blipFill>
         <p:spPr>
           <a:xfrm>
-            <a:off x="5084064" y="3794760"/>
+            <a:off x="5084064" y="3611880"/>
             <a:ext cx="182880" cy="182880"/>
           </a:xfrm>
           <a:prstGeom prst="rect">
@@ -1668,7 +1668,7 @@
         </p:nvSpPr>
         <p:spPr>
           <a:xfrm>
-            <a:off x="5577840" y="3694176"/>
+            <a:off x="5577840" y="3511296"/>
             <a:ext cx="2743200" cy="384048"/>
           </a:xfrm>
           <a:prstGeom prst="rect">
@@ -1704,7 +1704,7 @@
         </p:nvSpPr>
         <p:spPr>
           <a:xfrm>
-            <a:off x="4297680" y="2720340"/>
+            <a:off x="4297680" y="2537460"/>
             <a:ext cx="365760" cy="365760"/>
           </a:xfrm>
           <a:prstGeom prst="ellipse">
@@ -1732,7 +1732,7 @@
         </p:blipFill>
         <p:spPr>
           <a:xfrm>
-            <a:off x="4389120" y="2811780"/>
+            <a:off x="4389120" y="2628900"/>
             <a:ext cx="182880" cy="182880"/>
           </a:xfrm>
           <a:prstGeom prst="rect">
@@ -1748,8 +1748,8 @@
         </p:nvSpPr>
         <p:spPr>
           <a:xfrm>
-            <a:off x="548640" y="4434840"/>
-            <a:ext cx="8046720" cy="320040"/>
+            <a:off x="4023360" y="320040"/>
+            <a:ext cx="4572000" cy="274320"/>
           </a:xfrm>
           <a:prstGeom prst="rect">
             <a:avLst/>
@@ -1761,29 +1761,111 @@
           <a:bodyPr wrap="square" lIns="0" tIns="0" rIns="0" bIns="0" rtlCol="0" anchor="ctr"/>
           <a:lstStyle/>
           <a:p>
-            <a:pPr indent="0" marL="0">
+            <a:pPr algn="r" indent="0" marL="0">
               <a:buNone/>
             </a:pPr>
             <a:r>
-              <a:rPr lang="en-US" sz="1400" dirty="0">
+              <a:rPr lang="en-US" sz="1200" dirty="0">
                 <a:solidFill>
                   <a:srgbClr val="A9A5E0"/>
                 </a:solidFill>
               </a:rPr>
-              <a:t>Gepresenteerd door  </a:t>
+              <a:t>Door  </a:t>
             </a:r>
-            <a:pPr indent="0" marL="0">
+            <a:pPr algn="r" indent="0" marL="0">
               <a:buNone/>
             </a:pPr>
             <a:r>
-              <a:rPr lang="en-US" sz="1400" b="1" dirty="0">
+              <a:rPr lang="en-US" sz="1200" b="1" dirty="0">
                 <a:solidFill>
                   <a:srgbClr val="FFFFFF"/>
                 </a:solidFill>
               </a:rPr>
               <a:t>Mo B  ·  Mo ek  ·  Amir</a:t>
             </a:r>
-            <a:endParaRPr lang="en-US" sz="1400" dirty="0"/>
+            <a:endParaRPr lang="en-US" sz="1200" dirty="0"/>
+          </a:p>
+        </p:txBody>
+      </p:sp>
+      <p:sp>
+        <p:nvSpPr>
+          <p:cNvPr id="35" name="Takeaway pill"/>
+          <p:cNvSpPr/>
+          <p:nvPr/>
+        </p:nvSpPr>
+        <p:spPr>
+          <a:xfrm>
+            <a:off x="548640" y="4206240"/>
+            <a:ext cx="8046720" cy="566928"/>
+          </a:xfrm>
+          <a:prstGeom prst="roundRect">
+            <a:avLst>
+              <a:gd name="adj" fmla="val 50000"/>
+            </a:avLst>
+          </a:prstGeom>
+          <a:solidFill>
+            <a:schemeClr val="accent4"/>
+          </a:solidFill>
+          <a:ln/>
+        </p:spPr>
+      </p:sp>
+      <p:pic>
+        <p:nvPicPr>
+          <p:cNvPr id="36" name="Takeaway icon" descr="Welzijn">    </p:cNvPr>
+          <p:cNvPicPr>
+            <a:picLocks noChangeAspect="1"/>
+          </p:cNvPicPr>
+          <p:nvPr/>
+        </p:nvPicPr>
+        <p:blipFill>
+          <a:blip r:embed="rId10"/>
+          <a:stretch>
+            <a:fillRect/>
+          </a:stretch>
+        </p:blipFill>
+        <p:spPr>
+          <a:xfrm>
+            <a:off x="822960" y="4352544"/>
+            <a:ext cx="274320" cy="274320"/>
+          </a:xfrm>
+          <a:prstGeom prst="rect">
+            <a:avLst/>
+          </a:prstGeom>
+        </p:spPr>
+      </p:pic>
+      <p:sp>
+        <p:nvSpPr>
+          <p:cNvPr id="37" name="Takeaway"/>
+          <p:cNvSpPr txBox="1"/>
+          <p:nvPr/>
+        </p:nvSpPr>
+        <p:spPr>
+          <a:xfrm>
+            <a:off x="1325880" y="4206240"/>
+            <a:ext cx="7132320" cy="566928"/>
+          </a:xfrm>
+          <a:prstGeom prst="rect">
+            <a:avLst/>
+          </a:prstGeom>
+          <a:noFill/>
+          <a:ln/>
+        </p:spPr>
+        <p:txBody>
+          <a:bodyPr wrap="square" lIns="0" tIns="0" rIns="0" bIns="0" rtlCol="0" anchor="ctr"/>
+          <a:lstStyle/>
+          <a:p>
+            <a:pPr indent="0" marL="0">
+              <a:buNone/>
+            </a:pPr>
+            <a:r>
+              <a:rPr lang="en-US" sz="1700" b="1" dirty="0">
+                <a:solidFill>
+                  <a:srgbClr val="15143A"/>
+                </a:solidFill>
+              </a:rPr>
+              <a:t>Gezonde voeding en beweging beïnvloeden je mentaal welzijn positief</a:t>
+            </a:r>
+            <a:endParaRPr lang="en-US" sz="1700" dirty="0"/>
           </a:p>
         </p:txBody>
       </p:sp>

</xml_diff>